<commit_message>
Add blank white slide layout
</commit_message>
<xml_diff>
--- a/skills/vllm-omni-deck/assets/vllm-omni-blank-template.pptx
+++ b/skills/vllm-omni-deck/assets/vllm-omni-blank-template.pptx
@@ -12,6 +12,7 @@
     <p:sldId id="260" r:id="rId11"/>
     <p:sldId id="261" r:id="rId12"/>
     <p:sldId id="262" r:id="rId13"/>
+    <p:sldId id="263" r:id="rId14"/>
   </p:sldIdLst>
   <p:sldSz cx="9144000" cy="5143500" type="screen4x3"/>
   <p:notesSz cx="6858000" cy="9144000"/>
@@ -10371,6 +10372,32 @@
           </a:p>
         </p:txBody>
       </p:sp>
+    </p:spTree>
+  </p:cSld>
+  <p:clrMapOvr>
+    <a:masterClrMapping/>
+  </p:clrMapOvr>
+</p:sld>
+</file>
+
+<file path=ppt/slides/slide8.xml><?xml version="1.0" encoding="utf-8"?>
+<p:sld xmlns:a="http://schemas.openxmlformats.org/drawingml/2006/main" xmlns:p="http://schemas.openxmlformats.org/presentationml/2006/main" xmlns:r="http://schemas.openxmlformats.org/officeDocument/2006/relationships">
+  <p:cSld>
+    <p:bg>
+      <p:bgPr>
+        <a:solidFill>
+          <a:srgbClr val="FFFFFF"/>
+        </a:solidFill>
+        <a:effectLst/>
+      </p:bgPr>
+    </p:bg>
+    <p:spTree>
+      <p:nvGrpSpPr>
+        <p:cNvPr id="1" name=""/>
+        <p:cNvGrpSpPr/>
+        <p:nvPr/>
+      </p:nvGrpSpPr>
+      <p:grpSpPr/>
     </p:spTree>
   </p:cSld>
   <p:clrMapOvr>

</xml_diff>

<commit_message>
Brand the blank white slide layout
</commit_message>
<xml_diff>
--- a/skills/vllm-omni-deck/assets/vllm-omni-blank-template.pptx
+++ b/skills/vllm-omni-deck/assets/vllm-omni-blank-template.pptx
@@ -10398,6 +10398,284 @@
         <p:nvPr/>
       </p:nvGrpSpPr>
       <p:grpSpPr/>
+      <p:sp>
+        <p:nvSpPr>
+          <p:cNvPr id="2" name="TextBox 1"/>
+          <p:cNvSpPr txBox="1"/>
+          <p:nvPr/>
+        </p:nvSpPr>
+        <p:spPr>
+          <a:xfrm>
+            <a:off x="475488" y="219456"/>
+            <a:ext cx="4206240" cy="164592"/>
+          </a:xfrm>
+          <a:prstGeom prst="rect">
+            <a:avLst/>
+          </a:prstGeom>
+          <a:noFill/>
+        </p:spPr>
+        <p:txBody>
+          <a:bodyPr wrap="square" anchor="t" lIns="0" rIns="0" tIns="0" bIns="0">
+            <a:spAutoFit/>
+          </a:bodyPr>
+          <a:lstStyle/>
+          <a:p>
+            <a:pPr algn="l">
+              <a:lnSpc>
+                <a:spcPct val="100000"/>
+              </a:lnSpc>
+              <a:spcAft>
+                <a:spcPts val="0"/>
+              </a:spcAft>
+            </a:pPr>
+            <a:r>
+              <a:rPr sz="1200" b="1">
+                <a:solidFill>
+                  <a:srgbClr val="3B82F6"/>
+                </a:solidFill>
+                <a:latin typeface="Arial"/>
+              </a:rPr>
+              <a:t>BLANK 08  ·  WHITE CANVAS</a:t>
+            </a:r>
+          </a:p>
+        </p:txBody>
+      </p:sp>
+      <p:sp>
+        <p:nvSpPr>
+          <p:cNvPr id="3" name="Rectangle 2"/>
+          <p:cNvSpPr/>
+          <p:nvPr/>
+        </p:nvSpPr>
+        <p:spPr>
+          <a:xfrm>
+            <a:off x="475488" y="448056"/>
+            <a:ext cx="54864" cy="393192"/>
+          </a:xfrm>
+          <a:prstGeom prst="rect">
+            <a:avLst/>
+          </a:prstGeom>
+          <a:solidFill>
+            <a:srgbClr val="F5A623"/>
+          </a:solidFill>
+          <a:ln>
+            <a:noFill/>
+          </a:ln>
+        </p:spPr>
+        <p:style>
+          <a:lnRef idx="1">
+            <a:schemeClr val="accent1"/>
+          </a:lnRef>
+          <a:fillRef idx="3">
+            <a:schemeClr val="accent1"/>
+          </a:fillRef>
+          <a:effectRef idx="2">
+            <a:schemeClr val="accent1"/>
+          </a:effectRef>
+          <a:fontRef idx="minor">
+            <a:schemeClr val="lt1"/>
+          </a:fontRef>
+        </p:style>
+        <p:txBody>
+          <a:bodyPr rtlCol="0" anchor="ctr"/>
+          <a:lstStyle/>
+          <a:p>
+            <a:pPr algn="ctr"/>
+          </a:p>
+        </p:txBody>
+      </p:sp>
+      <p:sp>
+        <p:nvSpPr>
+          <p:cNvPr id="4" name="TextBox 3"/>
+          <p:cNvSpPr txBox="1"/>
+          <p:nvPr/>
+        </p:nvSpPr>
+        <p:spPr>
+          <a:xfrm>
+            <a:off x="621792" y="411480"/>
+            <a:ext cx="8065008" cy="457200"/>
+          </a:xfrm>
+          <a:prstGeom prst="rect">
+            <a:avLst/>
+          </a:prstGeom>
+          <a:noFill/>
+        </p:spPr>
+        <p:txBody>
+          <a:bodyPr wrap="square" anchor="t" lIns="0" rIns="0" tIns="0" bIns="0">
+            <a:spAutoFit/>
+          </a:bodyPr>
+          <a:lstStyle/>
+          <a:p>
+            <a:pPr algn="l">
+              <a:lnSpc>
+                <a:spcPct val="100000"/>
+              </a:lnSpc>
+              <a:spcAft>
+                <a:spcPts val="0"/>
+              </a:spcAft>
+            </a:pPr>
+            <a:r>
+              <a:rPr sz="2800" b="1">
+                <a:solidFill>
+                  <a:srgbClr val="172033"/>
+                </a:solidFill>
+                <a:latin typeface="Arial"/>
+              </a:rPr>
+              <a:t>[Slide title]</a:t>
+            </a:r>
+          </a:p>
+        </p:txBody>
+      </p:sp>
+      <p:sp>
+        <p:nvSpPr>
+          <p:cNvPr id="5" name="Rectangle 4"/>
+          <p:cNvSpPr/>
+          <p:nvPr/>
+        </p:nvSpPr>
+        <p:spPr>
+          <a:xfrm>
+            <a:off x="457200" y="4681728"/>
+            <a:ext cx="8229600" cy="10972"/>
+          </a:xfrm>
+          <a:prstGeom prst="rect">
+            <a:avLst/>
+          </a:prstGeom>
+          <a:solidFill>
+            <a:srgbClr val="D8E2EC"/>
+          </a:solidFill>
+          <a:ln>
+            <a:noFill/>
+          </a:ln>
+        </p:spPr>
+        <p:style>
+          <a:lnRef idx="1">
+            <a:schemeClr val="accent1"/>
+          </a:lnRef>
+          <a:fillRef idx="3">
+            <a:schemeClr val="accent1"/>
+          </a:fillRef>
+          <a:effectRef idx="2">
+            <a:schemeClr val="accent1"/>
+          </a:effectRef>
+          <a:fontRef idx="minor">
+            <a:schemeClr val="lt1"/>
+          </a:fontRef>
+        </p:style>
+        <p:txBody>
+          <a:bodyPr rtlCol="0" anchor="ctr"/>
+          <a:lstStyle/>
+          <a:p>
+            <a:pPr algn="ctr"/>
+          </a:p>
+        </p:txBody>
+      </p:sp>
+      <p:sp>
+        <p:nvSpPr>
+          <p:cNvPr id="6" name="TextBox 5"/>
+          <p:cNvSpPr txBox="1"/>
+          <p:nvPr/>
+        </p:nvSpPr>
+        <p:spPr>
+          <a:xfrm>
+            <a:off x="475488" y="4782312"/>
+            <a:ext cx="6309360" cy="182880"/>
+          </a:xfrm>
+          <a:prstGeom prst="rect">
+            <a:avLst/>
+          </a:prstGeom>
+          <a:noFill/>
+        </p:spPr>
+        <p:txBody>
+          <a:bodyPr wrap="square" anchor="t" lIns="0" rIns="0" tIns="0" bIns="0">
+            <a:spAutoFit/>
+          </a:bodyPr>
+          <a:lstStyle/>
+          <a:p>
+            <a:pPr algn="l">
+              <a:lnSpc>
+                <a:spcPct val="100000"/>
+              </a:lnSpc>
+              <a:spcAft>
+                <a:spcPts val="0"/>
+              </a:spcAft>
+            </a:pPr>
+            <a:r>
+              <a:rPr sz="1200" b="0">
+                <a:solidFill>
+                  <a:srgbClr val="5E6B7A"/>
+                </a:solidFill>
+                <a:latin typeface="Arial"/>
+              </a:rPr>
+              <a:t>[Source / context if required]</a:t>
+            </a:r>
+          </a:p>
+        </p:txBody>
+      </p:sp>
+      <p:pic>
+        <p:nvPicPr>
+          <p:cNvPr id="7" name="Picture 6" descr="vllm-omni-logo.png"/>
+          <p:cNvPicPr>
+            <a:picLocks noChangeAspect="1"/>
+          </p:cNvPicPr>
+          <p:nvPr/>
+        </p:nvPicPr>
+        <p:blipFill>
+          <a:blip r:embed="rId2"/>
+          <a:stretch>
+            <a:fillRect/>
+          </a:stretch>
+        </p:blipFill>
+        <p:spPr>
+          <a:xfrm>
+            <a:off x="7342631" y="4800600"/>
+            <a:ext cx="1078992" cy="196180"/>
+          </a:xfrm>
+          <a:prstGeom prst="rect">
+            <a:avLst/>
+          </a:prstGeom>
+        </p:spPr>
+      </p:pic>
+      <p:sp>
+        <p:nvSpPr>
+          <p:cNvPr id="8" name="TextBox 7"/>
+          <p:cNvSpPr txBox="1"/>
+          <p:nvPr/>
+        </p:nvSpPr>
+        <p:spPr>
+          <a:xfrm>
+            <a:off x="8540496" y="4782312"/>
+            <a:ext cx="182880" cy="182880"/>
+          </a:xfrm>
+          <a:prstGeom prst="rect">
+            <a:avLst/>
+          </a:prstGeom>
+          <a:noFill/>
+        </p:spPr>
+        <p:txBody>
+          <a:bodyPr wrap="square" anchor="t" lIns="0" rIns="0" tIns="0" bIns="0">
+            <a:spAutoFit/>
+          </a:bodyPr>
+          <a:lstStyle/>
+          <a:p>
+            <a:pPr algn="r">
+              <a:lnSpc>
+                <a:spcPct val="100000"/>
+              </a:lnSpc>
+              <a:spcAft>
+                <a:spcPts val="0"/>
+              </a:spcAft>
+            </a:pPr>
+            <a:r>
+              <a:rPr sz="1200" b="0">
+                <a:solidFill>
+                  <a:srgbClr val="5E6B7A"/>
+                </a:solidFill>
+                <a:latin typeface="Arial"/>
+              </a:rPr>
+              <a:t>08</a:t>
+            </a:r>
+          </a:p>
+        </p:txBody>
+      </p:sp>
     </p:spTree>
   </p:cSld>
   <p:clrMapOvr>

</xml_diff>

<commit_message>
Require intact source figures
</commit_message>
<xml_diff>
--- a/skills/vllm-omni-deck/assets/vllm-omni-blank-template.pptx
+++ b/skills/vllm-omni-deck/assets/vllm-omni-blank-template.pptx
@@ -3463,7 +3463,7 @@
                 </a:solidFill>
                 <a:latin typeface="Arial"/>
               </a:rPr>
-              <a:t>[Insert source figure or editable motif]</a:t>
+              <a:t>[Insert source figure unchanged or editable motif]</a:t>
             </a:r>
           </a:p>
         </p:txBody>
@@ -3896,7 +3896,7 @@
                 </a:solidFill>
                 <a:latin typeface="Arial"/>
               </a:rPr>
-              <a:t>[Insert source figure or semantic visual]</a:t>
+              <a:t>[Insert source figure unchanged or semantic visual]</a:t>
             </a:r>
           </a:p>
         </p:txBody>
@@ -5890,7 +5890,7 @@
                 </a:solidFill>
                 <a:latin typeface="Arial"/>
               </a:rPr>
-              <a:t>[Insert original source figure or editable visual]</a:t>
+              <a:t>[Insert original source figure unchanged]</a:t>
             </a:r>
           </a:p>
         </p:txBody>
@@ -6017,7 +6017,7 @@
                 </a:solidFill>
                 <a:latin typeface="Arial"/>
               </a:rPr>
-              <a:t>[Source / adapted from URL]</a:t>
+              <a:t>[Source URL]</a:t>
             </a:r>
           </a:p>
         </p:txBody>
@@ -7732,7 +7732,7 @@
                 </a:solidFill>
                 <a:latin typeface="Arial"/>
               </a:rPr>
-              <a:t>[Source / adapted from URL]</a:t>
+              <a:t>[Source URL]</a:t>
             </a:r>
           </a:p>
         </p:txBody>
@@ -8122,7 +8122,7 @@
                 </a:solidFill>
                 <a:latin typeface="Arial"/>
               </a:rPr>
-              <a:t>[Insert original figure — fit and preserve aspect ratio]</a:t>
+              <a:t>[Insert original figure unchanged — scale proportionally]</a:t>
             </a:r>
           </a:p>
         </p:txBody>
@@ -8207,7 +8207,7 @@
                 </a:solidFill>
                 <a:latin typeface="Arial"/>
               </a:rPr>
-              <a:t>[Caption  ·  Source or Adapted from URL]</a:t>
+              <a:t>[Caption  ·  Source URL]</a:t>
             </a:r>
           </a:p>
         </p:txBody>
@@ -8550,7 +8550,7 @@
                 </a:solidFill>
                 <a:latin typeface="Arial"/>
               </a:rPr>
-              <a:t>[Source / adapted from URL]</a:t>
+              <a:t>[Source URL]</a:t>
             </a:r>
           </a:p>
         </p:txBody>

</xml_diff>

<commit_message>
Add references layout to vLLM-Omni deck
</commit_message>
<xml_diff>
--- a/skills/vllm-omni-deck/assets/vllm-omni-blank-template.pptx
+++ b/skills/vllm-omni-deck/assets/vllm-omni-blank-template.pptx
@@ -13,6 +13,7 @@
     <p:sldId id="261" r:id="rId12"/>
     <p:sldId id="262" r:id="rId13"/>
     <p:sldId id="263" r:id="rId14"/>
+    <p:sldId id="264" r:id="rId15"/>
   </p:sldIdLst>
   <p:sldSz cx="9144000" cy="5143500" type="screen4x3"/>
   <p:notesSz cx="6858000" cy="9144000"/>
@@ -10672,6 +10673,1120 @@
                 <a:latin typeface="Arial"/>
               </a:rPr>
               <a:t>08</a:t>
+            </a:r>
+          </a:p>
+        </p:txBody>
+      </p:sp>
+    </p:spTree>
+  </p:cSld>
+  <p:clrMapOvr>
+    <a:masterClrMapping/>
+  </p:clrMapOvr>
+</p:sld>
+</file>
+
+<file path=ppt/slides/slide9.xml><?xml version="1.0" encoding="utf-8"?>
+<p:sld xmlns:a="http://schemas.openxmlformats.org/drawingml/2006/main" xmlns:p="http://schemas.openxmlformats.org/presentationml/2006/main" xmlns:r="http://schemas.openxmlformats.org/officeDocument/2006/relationships">
+  <p:cSld>
+    <p:bg>
+      <p:bgPr>
+        <a:solidFill>
+          <a:srgbClr val="FFFFFF"/>
+        </a:solidFill>
+        <a:effectLst/>
+      </p:bgPr>
+    </p:bg>
+    <p:spTree>
+      <p:nvGrpSpPr>
+        <p:cNvPr id="1" name=""/>
+        <p:cNvGrpSpPr/>
+        <p:nvPr/>
+      </p:nvGrpSpPr>
+      <p:grpSpPr/>
+      <p:sp>
+        <p:nvSpPr>
+          <p:cNvPr id="2" name="TextBox 1"/>
+          <p:cNvSpPr txBox="1"/>
+          <p:nvPr/>
+        </p:nvSpPr>
+        <p:spPr>
+          <a:xfrm>
+            <a:off x="475488" y="219456"/>
+            <a:ext cx="4206240" cy="164592"/>
+          </a:xfrm>
+          <a:prstGeom prst="rect">
+            <a:avLst/>
+          </a:prstGeom>
+          <a:noFill/>
+        </p:spPr>
+        <p:txBody>
+          <a:bodyPr wrap="square" anchor="t" lIns="0" rIns="0" tIns="0" bIns="0">
+            <a:spAutoFit/>
+          </a:bodyPr>
+          <a:lstStyle/>
+          <a:p>
+            <a:pPr algn="l">
+              <a:lnSpc>
+                <a:spcPct val="100000"/>
+              </a:lnSpc>
+              <a:spcAft>
+                <a:spcPts val="0"/>
+              </a:spcAft>
+            </a:pPr>
+            <a:r>
+              <a:rPr sz="1200" b="1">
+                <a:solidFill>
+                  <a:srgbClr val="3B82F6"/>
+                </a:solidFill>
+                <a:latin typeface="Arial"/>
+              </a:rPr>
+              <a:t>BLANK 09  ·  REFERENCES</a:t>
+            </a:r>
+          </a:p>
+        </p:txBody>
+      </p:sp>
+      <p:sp>
+        <p:nvSpPr>
+          <p:cNvPr id="3" name="Rectangle 2"/>
+          <p:cNvSpPr/>
+          <p:nvPr/>
+        </p:nvSpPr>
+        <p:spPr>
+          <a:xfrm>
+            <a:off x="475488" y="448056"/>
+            <a:ext cx="54864" cy="393192"/>
+          </a:xfrm>
+          <a:prstGeom prst="rect">
+            <a:avLst/>
+          </a:prstGeom>
+          <a:solidFill>
+            <a:srgbClr val="F5A623"/>
+          </a:solidFill>
+          <a:ln>
+            <a:noFill/>
+          </a:ln>
+        </p:spPr>
+        <p:style>
+          <a:lnRef idx="1">
+            <a:schemeClr val="accent1"/>
+          </a:lnRef>
+          <a:fillRef idx="3">
+            <a:schemeClr val="accent1"/>
+          </a:fillRef>
+          <a:effectRef idx="2">
+            <a:schemeClr val="accent1"/>
+          </a:effectRef>
+          <a:fontRef idx="minor">
+            <a:schemeClr val="lt1"/>
+          </a:fontRef>
+        </p:style>
+        <p:txBody>
+          <a:bodyPr rtlCol="0" anchor="ctr"/>
+          <a:lstStyle/>
+          <a:p>
+            <a:pPr algn="ctr"/>
+          </a:p>
+        </p:txBody>
+      </p:sp>
+      <p:sp>
+        <p:nvSpPr>
+          <p:cNvPr id="4" name="TextBox 3"/>
+          <p:cNvSpPr txBox="1"/>
+          <p:nvPr/>
+        </p:nvSpPr>
+        <p:spPr>
+          <a:xfrm>
+            <a:off x="621792" y="411480"/>
+            <a:ext cx="8065008" cy="457200"/>
+          </a:xfrm>
+          <a:prstGeom prst="rect">
+            <a:avLst/>
+          </a:prstGeom>
+          <a:noFill/>
+        </p:spPr>
+        <p:txBody>
+          <a:bodyPr wrap="square" anchor="t" lIns="0" rIns="0" tIns="0" bIns="0">
+            <a:spAutoFit/>
+          </a:bodyPr>
+          <a:lstStyle/>
+          <a:p>
+            <a:pPr algn="l">
+              <a:lnSpc>
+                <a:spcPct val="100000"/>
+              </a:lnSpc>
+              <a:spcAft>
+                <a:spcPts val="0"/>
+              </a:spcAft>
+            </a:pPr>
+            <a:r>
+              <a:rPr sz="2800" b="1">
+                <a:solidFill>
+                  <a:srgbClr val="172033"/>
+                </a:solidFill>
+                <a:latin typeface="Arial"/>
+              </a:rPr>
+              <a:t>[References and further reading]</a:t>
+            </a:r>
+          </a:p>
+        </p:txBody>
+      </p:sp>
+      <p:sp>
+        <p:nvSpPr>
+          <p:cNvPr id="5" name="TextBox 4"/>
+          <p:cNvSpPr txBox="1"/>
+          <p:nvPr/>
+        </p:nvSpPr>
+        <p:spPr>
+          <a:xfrm>
+            <a:off x="502920" y="1024128"/>
+            <a:ext cx="8138160" cy="201168"/>
+          </a:xfrm>
+          <a:prstGeom prst="rect">
+            <a:avLst/>
+          </a:prstGeom>
+          <a:noFill/>
+        </p:spPr>
+        <p:txBody>
+          <a:bodyPr wrap="square" anchor="t" lIns="0" rIns="0" tIns="0" bIns="0">
+            <a:spAutoFit/>
+          </a:bodyPr>
+          <a:lstStyle/>
+          <a:p>
+            <a:pPr algn="l">
+              <a:lnSpc>
+                <a:spcPct val="100000"/>
+              </a:lnSpc>
+              <a:spcAft>
+                <a:spcPts val="0"/>
+              </a:spcAft>
+            </a:pPr>
+            <a:r>
+              <a:rPr sz="1200" b="0">
+                <a:solidFill>
+                  <a:srgbClr val="5E6B7A"/>
+                </a:solidFill>
+                <a:latin typeface="Arial"/>
+              </a:rPr>
+              <a:t>[Use primary sources and retain version, date, identifier, and status]</a:t>
+            </a:r>
+          </a:p>
+        </p:txBody>
+      </p:sp>
+      <p:sp>
+        <p:nvSpPr>
+          <p:cNvPr id="6" name="Rounded Rectangle 5"/>
+          <p:cNvSpPr/>
+          <p:nvPr/>
+        </p:nvSpPr>
+        <p:spPr>
+          <a:xfrm>
+            <a:off x="502920" y="1362456"/>
+            <a:ext cx="8138160" cy="914400"/>
+          </a:xfrm>
+          <a:prstGeom prst="roundRect">
+            <a:avLst/>
+          </a:prstGeom>
+          <a:solidFill>
+            <a:srgbClr val="F4F7FB"/>
+          </a:solidFill>
+          <a:ln w="12700">
+            <a:solidFill>
+              <a:srgbClr val="D8E2EC"/>
+            </a:solidFill>
+          </a:ln>
+        </p:spPr>
+        <p:style>
+          <a:lnRef idx="1">
+            <a:schemeClr val="accent1"/>
+          </a:lnRef>
+          <a:fillRef idx="3">
+            <a:schemeClr val="accent1"/>
+          </a:fillRef>
+          <a:effectRef idx="2">
+            <a:schemeClr val="accent1"/>
+          </a:effectRef>
+          <a:fontRef idx="minor">
+            <a:schemeClr val="lt1"/>
+          </a:fontRef>
+        </p:style>
+        <p:txBody>
+          <a:bodyPr rtlCol="0" anchor="ctr"/>
+          <a:lstStyle/>
+          <a:p>
+            <a:pPr algn="ctr"/>
+          </a:p>
+        </p:txBody>
+      </p:sp>
+      <p:sp>
+        <p:nvSpPr>
+          <p:cNvPr id="7" name="Rectangle 6"/>
+          <p:cNvSpPr/>
+          <p:nvPr/>
+        </p:nvSpPr>
+        <p:spPr>
+          <a:xfrm>
+            <a:off x="502920" y="1362456"/>
+            <a:ext cx="64008" cy="914400"/>
+          </a:xfrm>
+          <a:prstGeom prst="rect">
+            <a:avLst/>
+          </a:prstGeom>
+          <a:solidFill>
+            <a:srgbClr val="3B82F6"/>
+          </a:solidFill>
+          <a:ln>
+            <a:noFill/>
+          </a:ln>
+        </p:spPr>
+        <p:style>
+          <a:lnRef idx="1">
+            <a:schemeClr val="accent1"/>
+          </a:lnRef>
+          <a:fillRef idx="3">
+            <a:schemeClr val="accent1"/>
+          </a:fillRef>
+          <a:effectRef idx="2">
+            <a:schemeClr val="accent1"/>
+          </a:effectRef>
+          <a:fontRef idx="minor">
+            <a:schemeClr val="lt1"/>
+          </a:fontRef>
+        </p:style>
+        <p:txBody>
+          <a:bodyPr rtlCol="0" anchor="ctr"/>
+          <a:lstStyle/>
+          <a:p>
+            <a:pPr algn="ctr"/>
+          </a:p>
+        </p:txBody>
+      </p:sp>
+      <p:sp>
+        <p:nvSpPr>
+          <p:cNvPr id="8" name="TextBox 7"/>
+          <p:cNvSpPr txBox="1"/>
+          <p:nvPr/>
+        </p:nvSpPr>
+        <p:spPr>
+          <a:xfrm>
+            <a:off x="667512" y="1728216"/>
+            <a:ext cx="1060704" cy="164592"/>
+          </a:xfrm>
+          <a:prstGeom prst="rect">
+            <a:avLst/>
+          </a:prstGeom>
+          <a:noFill/>
+        </p:spPr>
+        <p:txBody>
+          <a:bodyPr wrap="square" anchor="t" lIns="0" rIns="0" tIns="0" bIns="0">
+            <a:spAutoFit/>
+          </a:bodyPr>
+          <a:lstStyle/>
+          <a:p>
+            <a:pPr algn="ctr">
+              <a:lnSpc>
+                <a:spcPct val="100000"/>
+              </a:lnSpc>
+              <a:spcAft>
+                <a:spcPts val="0"/>
+              </a:spcAft>
+            </a:pPr>
+            <a:r>
+              <a:rPr sz="1200" b="1">
+                <a:solidFill>
+                  <a:srgbClr val="3B82F6"/>
+                </a:solidFill>
+                <a:latin typeface="Arial"/>
+              </a:rPr>
+              <a:t>[PAPER]</a:t>
+            </a:r>
+          </a:p>
+        </p:txBody>
+      </p:sp>
+      <p:sp>
+        <p:nvSpPr>
+          <p:cNvPr id="9" name="TextBox 8"/>
+          <p:cNvSpPr txBox="1"/>
+          <p:nvPr/>
+        </p:nvSpPr>
+        <p:spPr>
+          <a:xfrm>
+            <a:off x="1837943" y="1481328"/>
+            <a:ext cx="6574536" cy="310896"/>
+          </a:xfrm>
+          <a:prstGeom prst="rect">
+            <a:avLst/>
+          </a:prstGeom>
+          <a:noFill/>
+        </p:spPr>
+        <p:txBody>
+          <a:bodyPr wrap="square" anchor="t" lIns="0" rIns="0" tIns="0" bIns="0">
+            <a:spAutoFit/>
+          </a:bodyPr>
+          <a:lstStyle/>
+          <a:p>
+            <a:pPr algn="l">
+              <a:lnSpc>
+                <a:spcPct val="100000"/>
+              </a:lnSpc>
+              <a:spcAft>
+                <a:spcPts val="0"/>
+              </a:spcAft>
+            </a:pPr>
+            <a:r>
+              <a:rPr sz="1800" b="1">
+                <a:solidFill>
+                  <a:srgbClr val="172033"/>
+                </a:solidFill>
+                <a:latin typeface="Arial"/>
+              </a:rPr>
+              <a:t>[Paper title]</a:t>
+            </a:r>
+          </a:p>
+        </p:txBody>
+      </p:sp>
+      <p:sp>
+        <p:nvSpPr>
+          <p:cNvPr id="10" name="TextBox 9"/>
+          <p:cNvSpPr txBox="1"/>
+          <p:nvPr/>
+        </p:nvSpPr>
+        <p:spPr>
+          <a:xfrm>
+            <a:off x="1837943" y="1929384"/>
+            <a:ext cx="4224528" cy="182880"/>
+          </a:xfrm>
+          <a:prstGeom prst="rect">
+            <a:avLst/>
+          </a:prstGeom>
+          <a:noFill/>
+        </p:spPr>
+        <p:txBody>
+          <a:bodyPr wrap="square" anchor="t" lIns="0" rIns="0" tIns="0" bIns="0">
+            <a:spAutoFit/>
+          </a:bodyPr>
+          <a:lstStyle/>
+          <a:p>
+            <a:pPr algn="l">
+              <a:lnSpc>
+                <a:spcPct val="100000"/>
+              </a:lnSpc>
+              <a:spcAft>
+                <a:spcPts val="0"/>
+              </a:spcAft>
+            </a:pPr>
+            <a:r>
+              <a:rPr sz="1200" b="0">
+                <a:solidFill>
+                  <a:srgbClr val="5E6B7A"/>
+                </a:solidFill>
+                <a:latin typeface="Arial"/>
+              </a:rPr>
+              <a:t>[Authors  ·  venue  ·  year  ·  DOI or arXiv ID]</a:t>
+            </a:r>
+          </a:p>
+        </p:txBody>
+      </p:sp>
+      <p:sp>
+        <p:nvSpPr>
+          <p:cNvPr id="11" name="TextBox 10"/>
+          <p:cNvSpPr txBox="1"/>
+          <p:nvPr/>
+        </p:nvSpPr>
+        <p:spPr>
+          <a:xfrm>
+            <a:off x="6309360" y="1929384"/>
+            <a:ext cx="2103120" cy="182880"/>
+          </a:xfrm>
+          <a:prstGeom prst="rect">
+            <a:avLst/>
+          </a:prstGeom>
+          <a:noFill/>
+        </p:spPr>
+        <p:txBody>
+          <a:bodyPr wrap="square" anchor="t" lIns="0" rIns="0" tIns="0" bIns="0">
+            <a:spAutoFit/>
+          </a:bodyPr>
+          <a:lstStyle/>
+          <a:p>
+            <a:pPr algn="r">
+              <a:lnSpc>
+                <a:spcPct val="100000"/>
+              </a:lnSpc>
+              <a:spcAft>
+                <a:spcPts val="0"/>
+              </a:spcAft>
+            </a:pPr>
+            <a:r>
+              <a:rPr sz="1200" b="0">
+                <a:solidFill>
+                  <a:srgbClr val="3B82F6"/>
+                </a:solidFill>
+                <a:latin typeface="Arial"/>
+              </a:rPr>
+              <a:t>[Canonical URL]</a:t>
+            </a:r>
+          </a:p>
+        </p:txBody>
+      </p:sp>
+      <p:sp>
+        <p:nvSpPr>
+          <p:cNvPr id="12" name="Rounded Rectangle 11"/>
+          <p:cNvSpPr/>
+          <p:nvPr/>
+        </p:nvSpPr>
+        <p:spPr>
+          <a:xfrm>
+            <a:off x="502920" y="2423160"/>
+            <a:ext cx="8138160" cy="914400"/>
+          </a:xfrm>
+          <a:prstGeom prst="roundRect">
+            <a:avLst/>
+          </a:prstGeom>
+          <a:solidFill>
+            <a:srgbClr val="F4F7FB"/>
+          </a:solidFill>
+          <a:ln w="12700">
+            <a:solidFill>
+              <a:srgbClr val="D8E2EC"/>
+            </a:solidFill>
+          </a:ln>
+        </p:spPr>
+        <p:style>
+          <a:lnRef idx="1">
+            <a:schemeClr val="accent1"/>
+          </a:lnRef>
+          <a:fillRef idx="3">
+            <a:schemeClr val="accent1"/>
+          </a:fillRef>
+          <a:effectRef idx="2">
+            <a:schemeClr val="accent1"/>
+          </a:effectRef>
+          <a:fontRef idx="minor">
+            <a:schemeClr val="lt1"/>
+          </a:fontRef>
+        </p:style>
+        <p:txBody>
+          <a:bodyPr rtlCol="0" anchor="ctr"/>
+          <a:lstStyle/>
+          <a:p>
+            <a:pPr algn="ctr"/>
+          </a:p>
+        </p:txBody>
+      </p:sp>
+      <p:sp>
+        <p:nvSpPr>
+          <p:cNvPr id="13" name="Rectangle 12"/>
+          <p:cNvSpPr/>
+          <p:nvPr/>
+        </p:nvSpPr>
+        <p:spPr>
+          <a:xfrm>
+            <a:off x="502920" y="2423160"/>
+            <a:ext cx="64008" cy="914400"/>
+          </a:xfrm>
+          <a:prstGeom prst="rect">
+            <a:avLst/>
+          </a:prstGeom>
+          <a:solidFill>
+            <a:srgbClr val="F5A623"/>
+          </a:solidFill>
+          <a:ln>
+            <a:noFill/>
+          </a:ln>
+        </p:spPr>
+        <p:style>
+          <a:lnRef idx="1">
+            <a:schemeClr val="accent1"/>
+          </a:lnRef>
+          <a:fillRef idx="3">
+            <a:schemeClr val="accent1"/>
+          </a:fillRef>
+          <a:effectRef idx="2">
+            <a:schemeClr val="accent1"/>
+          </a:effectRef>
+          <a:fontRef idx="minor">
+            <a:schemeClr val="lt1"/>
+          </a:fontRef>
+        </p:style>
+        <p:txBody>
+          <a:bodyPr rtlCol="0" anchor="ctr"/>
+          <a:lstStyle/>
+          <a:p>
+            <a:pPr algn="ctr"/>
+          </a:p>
+        </p:txBody>
+      </p:sp>
+      <p:sp>
+        <p:nvSpPr>
+          <p:cNvPr id="14" name="TextBox 13"/>
+          <p:cNvSpPr txBox="1"/>
+          <p:nvPr/>
+        </p:nvSpPr>
+        <p:spPr>
+          <a:xfrm>
+            <a:off x="667512" y="2788920"/>
+            <a:ext cx="1060704" cy="164592"/>
+          </a:xfrm>
+          <a:prstGeom prst="rect">
+            <a:avLst/>
+          </a:prstGeom>
+          <a:noFill/>
+        </p:spPr>
+        <p:txBody>
+          <a:bodyPr wrap="square" anchor="t" lIns="0" rIns="0" tIns="0" bIns="0">
+            <a:spAutoFit/>
+          </a:bodyPr>
+          <a:lstStyle/>
+          <a:p>
+            <a:pPr algn="ctr">
+              <a:lnSpc>
+                <a:spcPct val="100000"/>
+              </a:lnSpc>
+              <a:spcAft>
+                <a:spcPts val="0"/>
+              </a:spcAft>
+            </a:pPr>
+            <a:r>
+              <a:rPr sz="1200" b="1">
+                <a:solidFill>
+                  <a:srgbClr val="F5A623"/>
+                </a:solidFill>
+                <a:latin typeface="Arial"/>
+              </a:rPr>
+              <a:t>[BLOG]</a:t>
+            </a:r>
+          </a:p>
+        </p:txBody>
+      </p:sp>
+      <p:sp>
+        <p:nvSpPr>
+          <p:cNvPr id="15" name="TextBox 14"/>
+          <p:cNvSpPr txBox="1"/>
+          <p:nvPr/>
+        </p:nvSpPr>
+        <p:spPr>
+          <a:xfrm>
+            <a:off x="1837943" y="2542032"/>
+            <a:ext cx="6574536" cy="310896"/>
+          </a:xfrm>
+          <a:prstGeom prst="rect">
+            <a:avLst/>
+          </a:prstGeom>
+          <a:noFill/>
+        </p:spPr>
+        <p:txBody>
+          <a:bodyPr wrap="square" anchor="t" lIns="0" rIns="0" tIns="0" bIns="0">
+            <a:spAutoFit/>
+          </a:bodyPr>
+          <a:lstStyle/>
+          <a:p>
+            <a:pPr algn="l">
+              <a:lnSpc>
+                <a:spcPct val="100000"/>
+              </a:lnSpc>
+              <a:spcAft>
+                <a:spcPts val="0"/>
+              </a:spcAft>
+            </a:pPr>
+            <a:r>
+              <a:rPr sz="1800" b="1">
+                <a:solidFill>
+                  <a:srgbClr val="172033"/>
+                </a:solidFill>
+                <a:latin typeface="Arial"/>
+              </a:rPr>
+              <a:t>[Blog post title]</a:t>
+            </a:r>
+          </a:p>
+        </p:txBody>
+      </p:sp>
+      <p:sp>
+        <p:nvSpPr>
+          <p:cNvPr id="16" name="TextBox 15"/>
+          <p:cNvSpPr txBox="1"/>
+          <p:nvPr/>
+        </p:nvSpPr>
+        <p:spPr>
+          <a:xfrm>
+            <a:off x="1837943" y="2990088"/>
+            <a:ext cx="4224528" cy="182880"/>
+          </a:xfrm>
+          <a:prstGeom prst="rect">
+            <a:avLst/>
+          </a:prstGeom>
+          <a:noFill/>
+        </p:spPr>
+        <p:txBody>
+          <a:bodyPr wrap="square" anchor="t" lIns="0" rIns="0" tIns="0" bIns="0">
+            <a:spAutoFit/>
+          </a:bodyPr>
+          <a:lstStyle/>
+          <a:p>
+            <a:pPr algn="l">
+              <a:lnSpc>
+                <a:spcPct val="100000"/>
+              </a:lnSpc>
+              <a:spcAft>
+                <a:spcPts val="0"/>
+              </a:spcAft>
+            </a:pPr>
+            <a:r>
+              <a:rPr sz="1200" b="0">
+                <a:solidFill>
+                  <a:srgbClr val="5E6B7A"/>
+                </a:solidFill>
+                <a:latin typeface="Arial"/>
+              </a:rPr>
+              <a:t>[Publisher or team  ·  published or updated YYYY-MM-DD]</a:t>
+            </a:r>
+          </a:p>
+        </p:txBody>
+      </p:sp>
+      <p:sp>
+        <p:nvSpPr>
+          <p:cNvPr id="17" name="TextBox 16"/>
+          <p:cNvSpPr txBox="1"/>
+          <p:nvPr/>
+        </p:nvSpPr>
+        <p:spPr>
+          <a:xfrm>
+            <a:off x="6309360" y="2990088"/>
+            <a:ext cx="2103120" cy="182880"/>
+          </a:xfrm>
+          <a:prstGeom prst="rect">
+            <a:avLst/>
+          </a:prstGeom>
+          <a:noFill/>
+        </p:spPr>
+        <p:txBody>
+          <a:bodyPr wrap="square" anchor="t" lIns="0" rIns="0" tIns="0" bIns="0">
+            <a:spAutoFit/>
+          </a:bodyPr>
+          <a:lstStyle/>
+          <a:p>
+            <a:pPr algn="r">
+              <a:lnSpc>
+                <a:spcPct val="100000"/>
+              </a:lnSpc>
+              <a:spcAft>
+                <a:spcPts val="0"/>
+              </a:spcAft>
+            </a:pPr>
+            <a:r>
+              <a:rPr sz="1200" b="0">
+                <a:solidFill>
+                  <a:srgbClr val="3B82F6"/>
+                </a:solidFill>
+                <a:latin typeface="Arial"/>
+              </a:rPr>
+              <a:t>[Canonical URL]</a:t>
+            </a:r>
+          </a:p>
+        </p:txBody>
+      </p:sp>
+      <p:sp>
+        <p:nvSpPr>
+          <p:cNvPr id="18" name="Rounded Rectangle 17"/>
+          <p:cNvSpPr/>
+          <p:nvPr/>
+        </p:nvSpPr>
+        <p:spPr>
+          <a:xfrm>
+            <a:off x="502920" y="3483864"/>
+            <a:ext cx="8138160" cy="914400"/>
+          </a:xfrm>
+          <a:prstGeom prst="roundRect">
+            <a:avLst/>
+          </a:prstGeom>
+          <a:solidFill>
+            <a:srgbClr val="F4F7FB"/>
+          </a:solidFill>
+          <a:ln w="12700">
+            <a:solidFill>
+              <a:srgbClr val="D8E2EC"/>
+            </a:solidFill>
+          </a:ln>
+        </p:spPr>
+        <p:style>
+          <a:lnRef idx="1">
+            <a:schemeClr val="accent1"/>
+          </a:lnRef>
+          <a:fillRef idx="3">
+            <a:schemeClr val="accent1"/>
+          </a:fillRef>
+          <a:effectRef idx="2">
+            <a:schemeClr val="accent1"/>
+          </a:effectRef>
+          <a:fontRef idx="minor">
+            <a:schemeClr val="lt1"/>
+          </a:fontRef>
+        </p:style>
+        <p:txBody>
+          <a:bodyPr rtlCol="0" anchor="ctr"/>
+          <a:lstStyle/>
+          <a:p>
+            <a:pPr algn="ctr"/>
+          </a:p>
+        </p:txBody>
+      </p:sp>
+      <p:sp>
+        <p:nvSpPr>
+          <p:cNvPr id="19" name="Rectangle 18"/>
+          <p:cNvSpPr/>
+          <p:nvPr/>
+        </p:nvSpPr>
+        <p:spPr>
+          <a:xfrm>
+            <a:off x="502920" y="3483864"/>
+            <a:ext cx="64008" cy="914400"/>
+          </a:xfrm>
+          <a:prstGeom prst="rect">
+            <a:avLst/>
+          </a:prstGeom>
+          <a:solidFill>
+            <a:srgbClr val="7C4DCC"/>
+          </a:solidFill>
+          <a:ln>
+            <a:noFill/>
+          </a:ln>
+        </p:spPr>
+        <p:style>
+          <a:lnRef idx="1">
+            <a:schemeClr val="accent1"/>
+          </a:lnRef>
+          <a:fillRef idx="3">
+            <a:schemeClr val="accent1"/>
+          </a:fillRef>
+          <a:effectRef idx="2">
+            <a:schemeClr val="accent1"/>
+          </a:effectRef>
+          <a:fontRef idx="minor">
+            <a:schemeClr val="lt1"/>
+          </a:fontRef>
+        </p:style>
+        <p:txBody>
+          <a:bodyPr rtlCol="0" anchor="ctr"/>
+          <a:lstStyle/>
+          <a:p>
+            <a:pPr algn="ctr"/>
+          </a:p>
+        </p:txBody>
+      </p:sp>
+      <p:sp>
+        <p:nvSpPr>
+          <p:cNvPr id="20" name="TextBox 19"/>
+          <p:cNvSpPr txBox="1"/>
+          <p:nvPr/>
+        </p:nvSpPr>
+        <p:spPr>
+          <a:xfrm>
+            <a:off x="667512" y="3849624"/>
+            <a:ext cx="1060704" cy="164592"/>
+          </a:xfrm>
+          <a:prstGeom prst="rect">
+            <a:avLst/>
+          </a:prstGeom>
+          <a:noFill/>
+        </p:spPr>
+        <p:txBody>
+          <a:bodyPr wrap="square" anchor="t" lIns="0" rIns="0" tIns="0" bIns="0">
+            <a:spAutoFit/>
+          </a:bodyPr>
+          <a:lstStyle/>
+          <a:p>
+            <a:pPr algn="ctr">
+              <a:lnSpc>
+                <a:spcPct val="100000"/>
+              </a:lnSpc>
+              <a:spcAft>
+                <a:spcPts val="0"/>
+              </a:spcAft>
+            </a:pPr>
+            <a:r>
+              <a:rPr sz="1200" b="1">
+                <a:solidFill>
+                  <a:srgbClr val="7C4DCC"/>
+                </a:solidFill>
+                <a:latin typeface="Arial"/>
+              </a:rPr>
+              <a:t>[PR]</a:t>
+            </a:r>
+          </a:p>
+        </p:txBody>
+      </p:sp>
+      <p:sp>
+        <p:nvSpPr>
+          <p:cNvPr id="21" name="TextBox 20"/>
+          <p:cNvSpPr txBox="1"/>
+          <p:nvPr/>
+        </p:nvSpPr>
+        <p:spPr>
+          <a:xfrm>
+            <a:off x="1837943" y="3602736"/>
+            <a:ext cx="6574536" cy="310896"/>
+          </a:xfrm>
+          <a:prstGeom prst="rect">
+            <a:avLst/>
+          </a:prstGeom>
+          <a:noFill/>
+        </p:spPr>
+        <p:txBody>
+          <a:bodyPr wrap="square" anchor="t" lIns="0" rIns="0" tIns="0" bIns="0">
+            <a:spAutoFit/>
+          </a:bodyPr>
+          <a:lstStyle/>
+          <a:p>
+            <a:pPr algn="l">
+              <a:lnSpc>
+                <a:spcPct val="100000"/>
+              </a:lnSpc>
+              <a:spcAft>
+                <a:spcPts val="0"/>
+              </a:spcAft>
+            </a:pPr>
+            <a:r>
+              <a:rPr sz="1800" b="1">
+                <a:solidFill>
+                  <a:srgbClr val="172033"/>
+                </a:solidFill>
+                <a:latin typeface="Arial"/>
+              </a:rPr>
+              <a:t>[Pull-request title]</a:t>
+            </a:r>
+          </a:p>
+        </p:txBody>
+      </p:sp>
+      <p:sp>
+        <p:nvSpPr>
+          <p:cNvPr id="22" name="TextBox 21"/>
+          <p:cNvSpPr txBox="1"/>
+          <p:nvPr/>
+        </p:nvSpPr>
+        <p:spPr>
+          <a:xfrm>
+            <a:off x="1837943" y="4050791"/>
+            <a:ext cx="4224528" cy="182880"/>
+          </a:xfrm>
+          <a:prstGeom prst="rect">
+            <a:avLst/>
+          </a:prstGeom>
+          <a:noFill/>
+        </p:spPr>
+        <p:txBody>
+          <a:bodyPr wrap="square" anchor="t" lIns="0" rIns="0" tIns="0" bIns="0">
+            <a:spAutoFit/>
+          </a:bodyPr>
+          <a:lstStyle/>
+          <a:p>
+            <a:pPr algn="l">
+              <a:lnSpc>
+                <a:spcPct val="100000"/>
+              </a:lnSpc>
+              <a:spcAft>
+                <a:spcPts val="0"/>
+              </a:spcAft>
+            </a:pPr>
+            <a:r>
+              <a:rPr sz="1200" b="0">
+                <a:solidFill>
+                  <a:srgbClr val="5E6B7A"/>
+                </a:solidFill>
+                <a:latin typeface="Arial"/>
+              </a:rPr>
+              <a:t>[org/repo  ·  PR #  ·  status  ·  date  ·  commit]</a:t>
+            </a:r>
+          </a:p>
+        </p:txBody>
+      </p:sp>
+      <p:sp>
+        <p:nvSpPr>
+          <p:cNvPr id="23" name="TextBox 22"/>
+          <p:cNvSpPr txBox="1"/>
+          <p:nvPr/>
+        </p:nvSpPr>
+        <p:spPr>
+          <a:xfrm>
+            <a:off x="6309360" y="4050791"/>
+            <a:ext cx="2103120" cy="182880"/>
+          </a:xfrm>
+          <a:prstGeom prst="rect">
+            <a:avLst/>
+          </a:prstGeom>
+          <a:noFill/>
+        </p:spPr>
+        <p:txBody>
+          <a:bodyPr wrap="square" anchor="t" lIns="0" rIns="0" tIns="0" bIns="0">
+            <a:spAutoFit/>
+          </a:bodyPr>
+          <a:lstStyle/>
+          <a:p>
+            <a:pPr algn="r">
+              <a:lnSpc>
+                <a:spcPct val="100000"/>
+              </a:lnSpc>
+              <a:spcAft>
+                <a:spcPts val="0"/>
+              </a:spcAft>
+            </a:pPr>
+            <a:r>
+              <a:rPr sz="1200" b="0">
+                <a:solidFill>
+                  <a:srgbClr val="3B82F6"/>
+                </a:solidFill>
+                <a:latin typeface="Arial"/>
+              </a:rPr>
+              <a:t>[Canonical URL]</a:t>
+            </a:r>
+          </a:p>
+        </p:txBody>
+      </p:sp>
+      <p:sp>
+        <p:nvSpPr>
+          <p:cNvPr id="24" name="Rectangle 23"/>
+          <p:cNvSpPr/>
+          <p:nvPr/>
+        </p:nvSpPr>
+        <p:spPr>
+          <a:xfrm>
+            <a:off x="457200" y="4681728"/>
+            <a:ext cx="8229600" cy="10972"/>
+          </a:xfrm>
+          <a:prstGeom prst="rect">
+            <a:avLst/>
+          </a:prstGeom>
+          <a:solidFill>
+            <a:srgbClr val="D8E2EC"/>
+          </a:solidFill>
+          <a:ln>
+            <a:noFill/>
+          </a:ln>
+        </p:spPr>
+        <p:style>
+          <a:lnRef idx="1">
+            <a:schemeClr val="accent1"/>
+          </a:lnRef>
+          <a:fillRef idx="3">
+            <a:schemeClr val="accent1"/>
+          </a:fillRef>
+          <a:effectRef idx="2">
+            <a:schemeClr val="accent1"/>
+          </a:effectRef>
+          <a:fontRef idx="minor">
+            <a:schemeClr val="lt1"/>
+          </a:fontRef>
+        </p:style>
+        <p:txBody>
+          <a:bodyPr rtlCol="0" anchor="ctr"/>
+          <a:lstStyle/>
+          <a:p>
+            <a:pPr algn="ctr"/>
+          </a:p>
+        </p:txBody>
+      </p:sp>
+      <p:sp>
+        <p:nvSpPr>
+          <p:cNvPr id="25" name="TextBox 24"/>
+          <p:cNvSpPr txBox="1"/>
+          <p:nvPr/>
+        </p:nvSpPr>
+        <p:spPr>
+          <a:xfrm>
+            <a:off x="475488" y="4782312"/>
+            <a:ext cx="6309360" cy="182880"/>
+          </a:xfrm>
+          <a:prstGeom prst="rect">
+            <a:avLst/>
+          </a:prstGeom>
+          <a:noFill/>
+        </p:spPr>
+        <p:txBody>
+          <a:bodyPr wrap="square" anchor="t" lIns="0" rIns="0" tIns="0" bIns="0">
+            <a:spAutoFit/>
+          </a:bodyPr>
+          <a:lstStyle/>
+          <a:p>
+            <a:pPr algn="l">
+              <a:lnSpc>
+                <a:spcPct val="100000"/>
+              </a:lnSpc>
+              <a:spcAft>
+                <a:spcPts val="0"/>
+              </a:spcAft>
+            </a:pPr>
+            <a:r>
+              <a:rPr sz="1200" b="0">
+                <a:solidFill>
+                  <a:srgbClr val="5E6B7A"/>
+                </a:solidFill>
+                <a:latin typeface="Arial"/>
+              </a:rPr>
+              <a:t>[Deck-wide source notes if required]</a:t>
+            </a:r>
+          </a:p>
+        </p:txBody>
+      </p:sp>
+      <p:pic>
+        <p:nvPicPr>
+          <p:cNvPr id="26" name="Picture 25" descr="vllm-omni-logo.png"/>
+          <p:cNvPicPr>
+            <a:picLocks noChangeAspect="1"/>
+          </p:cNvPicPr>
+          <p:nvPr/>
+        </p:nvPicPr>
+        <p:blipFill>
+          <a:blip r:embed="rId2"/>
+          <a:stretch>
+            <a:fillRect/>
+          </a:stretch>
+        </p:blipFill>
+        <p:spPr>
+          <a:xfrm>
+            <a:off x="7342631" y="4800600"/>
+            <a:ext cx="1078992" cy="196180"/>
+          </a:xfrm>
+          <a:prstGeom prst="rect">
+            <a:avLst/>
+          </a:prstGeom>
+        </p:spPr>
+      </p:pic>
+      <p:sp>
+        <p:nvSpPr>
+          <p:cNvPr id="27" name="TextBox 26"/>
+          <p:cNvSpPr txBox="1"/>
+          <p:nvPr/>
+        </p:nvSpPr>
+        <p:spPr>
+          <a:xfrm>
+            <a:off x="8540496" y="4782312"/>
+            <a:ext cx="182880" cy="182880"/>
+          </a:xfrm>
+          <a:prstGeom prst="rect">
+            <a:avLst/>
+          </a:prstGeom>
+          <a:noFill/>
+        </p:spPr>
+        <p:txBody>
+          <a:bodyPr wrap="square" anchor="t" lIns="0" rIns="0" tIns="0" bIns="0">
+            <a:spAutoFit/>
+          </a:bodyPr>
+          <a:lstStyle/>
+          <a:p>
+            <a:pPr algn="r">
+              <a:lnSpc>
+                <a:spcPct val="100000"/>
+              </a:lnSpc>
+              <a:spcAft>
+                <a:spcPts val="0"/>
+              </a:spcAft>
+            </a:pPr>
+            <a:r>
+              <a:rPr sz="1200" b="0">
+                <a:solidFill>
+                  <a:srgbClr val="5E6B7A"/>
+                </a:solidFill>
+                <a:latin typeface="Arial"/>
+              </a:rPr>
+              <a:t>09</a:t>
             </a:r>
           </a:p>
         </p:txBody>

</xml_diff>